<commit_message>
Finalize mf_analysis deliverables and add pipeline, schema, and README
</commit_message>
<xml_diff>
--- a/mf_analysis/Bluestock_MF_Presentation.pptx
+++ b/mf_analysis/Bluestock_MF_Presentation.pptx
@@ -6,6 +6,17 @@
   </p:sldMasterIdLst>
   <p:sldIdLst>
     <p:sldId id="256" r:id="rId7"/>
+    <p:sldId id="257" r:id="rId8"/>
+    <p:sldId id="258" r:id="rId9"/>
+    <p:sldId id="259" r:id="rId10"/>
+    <p:sldId id="260" r:id="rId11"/>
+    <p:sldId id="261" r:id="rId12"/>
+    <p:sldId id="262" r:id="rId13"/>
+    <p:sldId id="263" r:id="rId14"/>
+    <p:sldId id="264" r:id="rId15"/>
+    <p:sldId id="265" r:id="rId16"/>
+    <p:sldId id="266" r:id="rId17"/>
+    <p:sldId id="267" r:id="rId18"/>
   </p:sldIdLst>
   <p:sldSz cx="9144000" cy="6858000" type="screen4x3"/>
   <p:notesSz cx="6858000" cy="9144000"/>
@@ -3104,7 +3115,7 @@
           <a:lstStyle/>
           <a:p>
             <a:r>
-              <a:t>Bluestock MF — Presentation</a:t>
+              <a:t>Bluestock MF Capstone</a:t>
             </a:r>
           </a:p>
         </p:txBody>
@@ -3125,7 +3136,700 @@
           <a:lstStyle/>
           <a:p>
             <a:r>
-              <a:t>12-slide summary generated by build_presentation.py</a:t>
+              <a:t>Final project presentation for mutual fund analytics and dashboard reporting.</a:t>
+            </a:r>
+          </a:p>
+        </p:txBody>
+      </p:sp>
+    </p:spTree>
+  </p:cSld>
+  <p:clrMapOvr>
+    <a:masterClrMapping/>
+  </p:clrMapOvr>
+</p:sld>
+</file>
+
+<file path=ppt/slides/slide10.xml><?xml version="1.0" encoding="utf-8"?>
+<p:sld xmlns:a="http://schemas.openxmlformats.org/drawingml/2006/main" xmlns:p="http://schemas.openxmlformats.org/presentationml/2006/main" xmlns:r="http://schemas.openxmlformats.org/officeDocument/2006/relationships">
+  <p:cSld>
+    <p:spTree>
+      <p:nvGrpSpPr>
+        <p:cNvPr id="1" name=""/>
+        <p:cNvGrpSpPr/>
+        <p:nvPr/>
+      </p:nvGrpSpPr>
+      <p:grpSpPr/>
+      <p:sp>
+        <p:nvSpPr>
+          <p:cNvPr id="2" name="Title 1"/>
+          <p:cNvSpPr>
+            <a:spLocks noGrp="1"/>
+          </p:cNvSpPr>
+          <p:nvPr>
+            <p:ph type="title"/>
+          </p:nvPr>
+        </p:nvSpPr>
+        <p:spPr/>
+        <p:txBody>
+          <a:bodyPr/>
+          <a:lstStyle/>
+          <a:p>
+            <a:r>
+              <a:t>Dashboard Screenshots</a:t>
+            </a:r>
+          </a:p>
+        </p:txBody>
+      </p:sp>
+      <p:sp>
+        <p:nvSpPr>
+          <p:cNvPr id="3" name="Content Placeholder 2"/>
+          <p:cNvSpPr>
+            <a:spLocks noGrp="1"/>
+          </p:cNvSpPr>
+          <p:nvPr>
+            <p:ph idx="1"/>
+          </p:nvPr>
+        </p:nvSpPr>
+        <p:spPr/>
+        <p:txBody>
+          <a:bodyPr/>
+          <a:lstStyle/>
+          <a:p>
+            <a:pPr>
+              <a:defRPr sz="1800"/>
+            </a:pPr>
+            <a:r>
+              <a:t>The interactive reporting layout supports stakeholder review and executive decisions.</a:t>
+            </a:r>
+          </a:p>
+        </p:txBody>
+      </p:sp>
+    </p:spTree>
+  </p:cSld>
+  <p:clrMapOvr>
+    <a:masterClrMapping/>
+  </p:clrMapOvr>
+</p:sld>
+</file>
+
+<file path=ppt/slides/slide11.xml><?xml version="1.0" encoding="utf-8"?>
+<p:sld xmlns:a="http://schemas.openxmlformats.org/drawingml/2006/main" xmlns:p="http://schemas.openxmlformats.org/presentationml/2006/main" xmlns:r="http://schemas.openxmlformats.org/officeDocument/2006/relationships">
+  <p:cSld>
+    <p:spTree>
+      <p:nvGrpSpPr>
+        <p:cNvPr id="1" name=""/>
+        <p:cNvGrpSpPr/>
+        <p:nvPr/>
+      </p:nvGrpSpPr>
+      <p:grpSpPr/>
+      <p:sp>
+        <p:nvSpPr>
+          <p:cNvPr id="2" name="Title 1"/>
+          <p:cNvSpPr>
+            <a:spLocks noGrp="1"/>
+          </p:cNvSpPr>
+          <p:nvPr>
+            <p:ph type="title"/>
+          </p:nvPr>
+        </p:nvSpPr>
+        <p:spPr/>
+        <p:txBody>
+          <a:bodyPr/>
+          <a:lstStyle/>
+          <a:p>
+            <a:r>
+              <a:t>Key Findings</a:t>
+            </a:r>
+          </a:p>
+        </p:txBody>
+      </p:sp>
+      <p:sp>
+        <p:nvSpPr>
+          <p:cNvPr id="3" name="Content Placeholder 2"/>
+          <p:cNvSpPr>
+            <a:spLocks noGrp="1"/>
+          </p:cNvSpPr>
+          <p:nvPr>
+            <p:ph idx="1"/>
+          </p:nvPr>
+        </p:nvSpPr>
+        <p:spPr/>
+        <p:txBody>
+          <a:bodyPr/>
+          <a:lstStyle/>
+          <a:p>
+            <a:pPr>
+              <a:defRPr sz="1800"/>
+            </a:pPr>
+            <a:r>
+              <a:t>Focus on risk-adjusted returns, expense management, sector concentration, and consistent SIP investor engagement for portfolio selection.</a:t>
+            </a:r>
+          </a:p>
+        </p:txBody>
+      </p:sp>
+    </p:spTree>
+  </p:cSld>
+  <p:clrMapOvr>
+    <a:masterClrMapping/>
+  </p:clrMapOvr>
+</p:sld>
+</file>
+
+<file path=ppt/slides/slide12.xml><?xml version="1.0" encoding="utf-8"?>
+<p:sld xmlns:a="http://schemas.openxmlformats.org/drawingml/2006/main" xmlns:p="http://schemas.openxmlformats.org/presentationml/2006/main" xmlns:r="http://schemas.openxmlformats.org/officeDocument/2006/relationships">
+  <p:cSld>
+    <p:spTree>
+      <p:nvGrpSpPr>
+        <p:cNvPr id="1" name=""/>
+        <p:cNvGrpSpPr/>
+        <p:nvPr/>
+      </p:nvGrpSpPr>
+      <p:grpSpPr/>
+      <p:sp>
+        <p:nvSpPr>
+          <p:cNvPr id="2" name="Title 1"/>
+          <p:cNvSpPr>
+            <a:spLocks noGrp="1"/>
+          </p:cNvSpPr>
+          <p:nvPr>
+            <p:ph type="title"/>
+          </p:nvPr>
+        </p:nvSpPr>
+        <p:spPr/>
+        <p:txBody>
+          <a:bodyPr/>
+          <a:lstStyle/>
+          <a:p>
+            <a:r>
+              <a:t>Thank You</a:t>
+            </a:r>
+          </a:p>
+        </p:txBody>
+      </p:sp>
+      <p:sp>
+        <p:nvSpPr>
+          <p:cNvPr id="3" name="Content Placeholder 2"/>
+          <p:cNvSpPr>
+            <a:spLocks noGrp="1"/>
+          </p:cNvSpPr>
+          <p:nvPr>
+            <p:ph idx="1"/>
+          </p:nvPr>
+        </p:nvSpPr>
+        <p:spPr/>
+        <p:txBody>
+          <a:bodyPr/>
+          <a:lstStyle/>
+          <a:p>
+            <a:pPr>
+              <a:defRPr sz="1800"/>
+            </a:pPr>
+            <a:r>
+              <a:t>Thank you for reviewing the Bluestock MF capstone analysis. Questions welcome.</a:t>
+            </a:r>
+          </a:p>
+        </p:txBody>
+      </p:sp>
+    </p:spTree>
+  </p:cSld>
+  <p:clrMapOvr>
+    <a:masterClrMapping/>
+  </p:clrMapOvr>
+</p:sld>
+</file>
+
+<file path=ppt/slides/slide2.xml><?xml version="1.0" encoding="utf-8"?>
+<p:sld xmlns:a="http://schemas.openxmlformats.org/drawingml/2006/main" xmlns:p="http://schemas.openxmlformats.org/presentationml/2006/main" xmlns:r="http://schemas.openxmlformats.org/officeDocument/2006/relationships">
+  <p:cSld>
+    <p:spTree>
+      <p:nvGrpSpPr>
+        <p:cNvPr id="1" name=""/>
+        <p:cNvGrpSpPr/>
+        <p:nvPr/>
+      </p:nvGrpSpPr>
+      <p:grpSpPr/>
+      <p:sp>
+        <p:nvSpPr>
+          <p:cNvPr id="2" name="Title 1"/>
+          <p:cNvSpPr>
+            <a:spLocks noGrp="1"/>
+          </p:cNvSpPr>
+          <p:nvPr>
+            <p:ph type="title"/>
+          </p:nvPr>
+        </p:nvSpPr>
+        <p:spPr/>
+        <p:txBody>
+          <a:bodyPr/>
+          <a:lstStyle/>
+          <a:p>
+            <a:r>
+              <a:t>Problem &amp; Objective</a:t>
+            </a:r>
+          </a:p>
+        </p:txBody>
+      </p:sp>
+      <p:sp>
+        <p:nvSpPr>
+          <p:cNvPr id="3" name="Content Placeholder 2"/>
+          <p:cNvSpPr>
+            <a:spLocks noGrp="1"/>
+          </p:cNvSpPr>
+          <p:nvPr>
+            <p:ph idx="1"/>
+          </p:nvPr>
+        </p:nvSpPr>
+        <p:spPr/>
+        <p:txBody>
+          <a:bodyPr/>
+          <a:lstStyle/>
+          <a:p>
+            <a:pPr>
+              <a:defRPr sz="1800"/>
+            </a:pPr>
+            <a:r>
+              <a:t>Problem: Identify top mutual fund schemes in India using data-driven analytics. Objective: Build a repeatable ETL and reporting pipeline that supports investment comparison and dashboard visualization.</a:t>
+            </a:r>
+          </a:p>
+        </p:txBody>
+      </p:sp>
+    </p:spTree>
+  </p:cSld>
+  <p:clrMapOvr>
+    <a:masterClrMapping/>
+  </p:clrMapOvr>
+</p:sld>
+</file>
+
+<file path=ppt/slides/slide3.xml><?xml version="1.0" encoding="utf-8"?>
+<p:sld xmlns:a="http://schemas.openxmlformats.org/drawingml/2006/main" xmlns:p="http://schemas.openxmlformats.org/presentationml/2006/main" xmlns:r="http://schemas.openxmlformats.org/officeDocument/2006/relationships">
+  <p:cSld>
+    <p:spTree>
+      <p:nvGrpSpPr>
+        <p:cNvPr id="1" name=""/>
+        <p:cNvGrpSpPr/>
+        <p:nvPr/>
+      </p:nvGrpSpPr>
+      <p:grpSpPr/>
+      <p:sp>
+        <p:nvSpPr>
+          <p:cNvPr id="2" name="Title 1"/>
+          <p:cNvSpPr>
+            <a:spLocks noGrp="1"/>
+          </p:cNvSpPr>
+          <p:nvPr>
+            <p:ph type="title"/>
+          </p:nvPr>
+        </p:nvSpPr>
+        <p:spPr/>
+        <p:txBody>
+          <a:bodyPr/>
+          <a:lstStyle/>
+          <a:p>
+            <a:r>
+              <a:t>Data Sources</a:t>
+            </a:r>
+          </a:p>
+        </p:txBody>
+      </p:sp>
+      <p:sp>
+        <p:nvSpPr>
+          <p:cNvPr id="3" name="Content Placeholder 2"/>
+          <p:cNvSpPr>
+            <a:spLocks noGrp="1"/>
+          </p:cNvSpPr>
+          <p:nvPr>
+            <p:ph idx="1"/>
+          </p:nvPr>
+        </p:nvSpPr>
+        <p:spPr/>
+        <p:txBody>
+          <a:bodyPr/>
+          <a:lstStyle/>
+          <a:p>
+            <a:pPr>
+              <a:defRPr sz="1800"/>
+            </a:pPr>
+            <a:r>
+              <a:t>Data sources include scheme metadata, NAV history, benchmark series, SIP transactions, AUM, expense ratio, fund managers, and risk metrics. Live NAV is fetched from MFAPI.</a:t>
+            </a:r>
+          </a:p>
+        </p:txBody>
+      </p:sp>
+    </p:spTree>
+  </p:cSld>
+  <p:clrMapOvr>
+    <a:masterClrMapping/>
+  </p:clrMapOvr>
+</p:sld>
+</file>
+
+<file path=ppt/slides/slide4.xml><?xml version="1.0" encoding="utf-8"?>
+<p:sld xmlns:a="http://schemas.openxmlformats.org/drawingml/2006/main" xmlns:p="http://schemas.openxmlformats.org/presentationml/2006/main" xmlns:r="http://schemas.openxmlformats.org/officeDocument/2006/relationships">
+  <p:cSld>
+    <p:spTree>
+      <p:nvGrpSpPr>
+        <p:cNvPr id="1" name=""/>
+        <p:cNvGrpSpPr/>
+        <p:nvPr/>
+      </p:nvGrpSpPr>
+      <p:grpSpPr/>
+      <p:sp>
+        <p:nvSpPr>
+          <p:cNvPr id="2" name="Title 1"/>
+          <p:cNvSpPr>
+            <a:spLocks noGrp="1"/>
+          </p:cNvSpPr>
+          <p:nvPr>
+            <p:ph type="title"/>
+          </p:nvPr>
+        </p:nvSpPr>
+        <p:spPr/>
+        <p:txBody>
+          <a:bodyPr/>
+          <a:lstStyle/>
+          <a:p>
+            <a:r>
+              <a:t>Architecture</a:t>
+            </a:r>
+          </a:p>
+        </p:txBody>
+      </p:sp>
+      <p:sp>
+        <p:nvSpPr>
+          <p:cNvPr id="3" name="Content Placeholder 2"/>
+          <p:cNvSpPr>
+            <a:spLocks noGrp="1"/>
+          </p:cNvSpPr>
+          <p:nvPr>
+            <p:ph idx="1"/>
+          </p:nvPr>
+        </p:nvSpPr>
+        <p:spPr/>
+        <p:txBody>
+          <a:bodyPr/>
+          <a:lstStyle/>
+          <a:p>
+            <a:pPr>
+              <a:defRPr sz="1800"/>
+            </a:pPr>
+            <a:r>
+              <a:t>The solution uses a structured ETL pipeline: dataset generation, data cleaning, database load, EDA, analytics, and deliverable generation with automated scripts.</a:t>
+            </a:r>
+          </a:p>
+        </p:txBody>
+      </p:sp>
+    </p:spTree>
+  </p:cSld>
+  <p:clrMapOvr>
+    <a:masterClrMapping/>
+  </p:clrMapOvr>
+</p:sld>
+</file>
+
+<file path=ppt/slides/slide5.xml><?xml version="1.0" encoding="utf-8"?>
+<p:sld xmlns:a="http://schemas.openxmlformats.org/drawingml/2006/main" xmlns:p="http://schemas.openxmlformats.org/presentationml/2006/main" xmlns:r="http://schemas.openxmlformats.org/officeDocument/2006/relationships">
+  <p:cSld>
+    <p:spTree>
+      <p:nvGrpSpPr>
+        <p:cNvPr id="1" name=""/>
+        <p:cNvGrpSpPr/>
+        <p:nvPr/>
+      </p:nvGrpSpPr>
+      <p:grpSpPr/>
+      <p:sp>
+        <p:nvSpPr>
+          <p:cNvPr id="2" name="Title 1"/>
+          <p:cNvSpPr>
+            <a:spLocks noGrp="1"/>
+          </p:cNvSpPr>
+          <p:nvPr>
+            <p:ph type="title"/>
+          </p:nvPr>
+        </p:nvSpPr>
+        <p:spPr/>
+        <p:txBody>
+          <a:bodyPr/>
+          <a:lstStyle/>
+          <a:p>
+            <a:r>
+              <a:t>EDA Highlights</a:t>
+            </a:r>
+          </a:p>
+        </p:txBody>
+      </p:sp>
+      <p:sp>
+        <p:nvSpPr>
+          <p:cNvPr id="3" name="Content Placeholder 2"/>
+          <p:cNvSpPr>
+            <a:spLocks noGrp="1"/>
+          </p:cNvSpPr>
+          <p:nvPr>
+            <p:ph idx="1"/>
+          </p:nvPr>
+        </p:nvSpPr>
+        <p:spPr/>
+        <p:txBody>
+          <a:bodyPr/>
+          <a:lstStyle/>
+          <a:p>
+            <a:pPr>
+              <a:defRPr sz="1800"/>
+            </a:pPr>
+            <a:r>
+              <a:t>NAV distribution and volatility patterns across large-cap schemes. Relationship between expense ratio and risk-adjusted return.</a:t>
+            </a:r>
+          </a:p>
+        </p:txBody>
+      </p:sp>
+    </p:spTree>
+  </p:cSld>
+  <p:clrMapOvr>
+    <a:masterClrMapping/>
+  </p:clrMapOvr>
+</p:sld>
+</file>
+
+<file path=ppt/slides/slide6.xml><?xml version="1.0" encoding="utf-8"?>
+<p:sld xmlns:a="http://schemas.openxmlformats.org/drawingml/2006/main" xmlns:p="http://schemas.openxmlformats.org/presentationml/2006/main" xmlns:r="http://schemas.openxmlformats.org/officeDocument/2006/relationships">
+  <p:cSld>
+    <p:spTree>
+      <p:nvGrpSpPr>
+        <p:cNvPr id="1" name=""/>
+        <p:cNvGrpSpPr/>
+        <p:nvPr/>
+      </p:nvGrpSpPr>
+      <p:grpSpPr/>
+      <p:sp>
+        <p:nvSpPr>
+          <p:cNvPr id="2" name="Title 1"/>
+          <p:cNvSpPr>
+            <a:spLocks noGrp="1"/>
+          </p:cNvSpPr>
+          <p:nvPr>
+            <p:ph type="title"/>
+          </p:nvPr>
+        </p:nvSpPr>
+        <p:spPr/>
+        <p:txBody>
+          <a:bodyPr/>
+          <a:lstStyle/>
+          <a:p>
+            <a:r>
+              <a:t>EDA Highlights</a:t>
+            </a:r>
+          </a:p>
+        </p:txBody>
+      </p:sp>
+      <p:sp>
+        <p:nvSpPr>
+          <p:cNvPr id="3" name="Content Placeholder 2"/>
+          <p:cNvSpPr>
+            <a:spLocks noGrp="1"/>
+          </p:cNvSpPr>
+          <p:nvPr>
+            <p:ph idx="1"/>
+          </p:nvPr>
+        </p:nvSpPr>
+        <p:spPr/>
+        <p:txBody>
+          <a:bodyPr/>
+          <a:lstStyle/>
+          <a:p>
+            <a:pPr>
+              <a:defRPr sz="1800"/>
+            </a:pPr>
+            <a:r>
+              <a:t>Correlation and portfolio composition analysis reveal sector concentration and risk profiles across schemes.</a:t>
+            </a:r>
+          </a:p>
+        </p:txBody>
+      </p:sp>
+    </p:spTree>
+  </p:cSld>
+  <p:clrMapOvr>
+    <a:masterClrMapping/>
+  </p:clrMapOvr>
+</p:sld>
+</file>
+
+<file path=ppt/slides/slide7.xml><?xml version="1.0" encoding="utf-8"?>
+<p:sld xmlns:a="http://schemas.openxmlformats.org/drawingml/2006/main" xmlns:p="http://schemas.openxmlformats.org/presentationml/2006/main" xmlns:r="http://schemas.openxmlformats.org/officeDocument/2006/relationships">
+  <p:cSld>
+    <p:spTree>
+      <p:nvGrpSpPr>
+        <p:cNvPr id="1" name=""/>
+        <p:cNvGrpSpPr/>
+        <p:nvPr/>
+      </p:nvGrpSpPr>
+      <p:grpSpPr/>
+      <p:sp>
+        <p:nvSpPr>
+          <p:cNvPr id="2" name="Title 1"/>
+          <p:cNvSpPr>
+            <a:spLocks noGrp="1"/>
+          </p:cNvSpPr>
+          <p:nvPr>
+            <p:ph type="title"/>
+          </p:nvPr>
+        </p:nvSpPr>
+        <p:spPr/>
+        <p:txBody>
+          <a:bodyPr/>
+          <a:lstStyle/>
+          <a:p>
+            <a:r>
+              <a:t>Performance Metrics</a:t>
+            </a:r>
+          </a:p>
+        </p:txBody>
+      </p:sp>
+      <p:sp>
+        <p:nvSpPr>
+          <p:cNvPr id="3" name="Content Placeholder 2"/>
+          <p:cNvSpPr>
+            <a:spLocks noGrp="1"/>
+          </p:cNvSpPr>
+          <p:nvPr>
+            <p:ph idx="1"/>
+          </p:nvPr>
+        </p:nvSpPr>
+        <p:spPr/>
+        <p:txBody>
+          <a:bodyPr/>
+          <a:lstStyle/>
+          <a:p>
+            <a:pPr>
+              <a:defRPr sz="1800"/>
+            </a:pPr>
+            <a:r>
+              <a:t>CAGR, Sharpe ratio, Sortino ratio, alpha/beta, drawdown, and fund scorecard metrics show scheme performance across horizons.</a:t>
+            </a:r>
+          </a:p>
+        </p:txBody>
+      </p:sp>
+    </p:spTree>
+  </p:cSld>
+  <p:clrMapOvr>
+    <a:masterClrMapping/>
+  </p:clrMapOvr>
+</p:sld>
+</file>
+
+<file path=ppt/slides/slide8.xml><?xml version="1.0" encoding="utf-8"?>
+<p:sld xmlns:a="http://schemas.openxmlformats.org/drawingml/2006/main" xmlns:p="http://schemas.openxmlformats.org/presentationml/2006/main" xmlns:r="http://schemas.openxmlformats.org/officeDocument/2006/relationships">
+  <p:cSld>
+    <p:spTree>
+      <p:nvGrpSpPr>
+        <p:cNvPr id="1" name=""/>
+        <p:cNvGrpSpPr/>
+        <p:nvPr/>
+      </p:nvGrpSpPr>
+      <p:grpSpPr/>
+      <p:sp>
+        <p:nvSpPr>
+          <p:cNvPr id="2" name="Title 1"/>
+          <p:cNvSpPr>
+            <a:spLocks noGrp="1"/>
+          </p:cNvSpPr>
+          <p:nvPr>
+            <p:ph type="title"/>
+          </p:nvPr>
+        </p:nvSpPr>
+        <p:spPr/>
+        <p:txBody>
+          <a:bodyPr/>
+          <a:lstStyle/>
+          <a:p>
+            <a:r>
+              <a:t>Performance Metrics</a:t>
+            </a:r>
+          </a:p>
+        </p:txBody>
+      </p:sp>
+      <p:sp>
+        <p:nvSpPr>
+          <p:cNvPr id="3" name="Content Placeholder 2"/>
+          <p:cNvSpPr>
+            <a:spLocks noGrp="1"/>
+          </p:cNvSpPr>
+          <p:nvPr>
+            <p:ph idx="1"/>
+          </p:nvPr>
+        </p:nvSpPr>
+        <p:spPr/>
+        <p:txBody>
+          <a:bodyPr/>
+          <a:lstStyle/>
+          <a:p>
+            <a:pPr>
+              <a:defRPr sz="1800"/>
+            </a:pPr>
+            <a:r>
+              <a:t>VaR/CVaR and SIP continuity analysis support downside risk evaluation and investor behavior insights.</a:t>
+            </a:r>
+          </a:p>
+        </p:txBody>
+      </p:sp>
+    </p:spTree>
+  </p:cSld>
+  <p:clrMapOvr>
+    <a:masterClrMapping/>
+  </p:clrMapOvr>
+</p:sld>
+</file>
+
+<file path=ppt/slides/slide9.xml><?xml version="1.0" encoding="utf-8"?>
+<p:sld xmlns:a="http://schemas.openxmlformats.org/drawingml/2006/main" xmlns:p="http://schemas.openxmlformats.org/presentationml/2006/main" xmlns:r="http://schemas.openxmlformats.org/officeDocument/2006/relationships">
+  <p:cSld>
+    <p:spTree>
+      <p:nvGrpSpPr>
+        <p:cNvPr id="1" name=""/>
+        <p:cNvGrpSpPr/>
+        <p:nvPr/>
+      </p:nvGrpSpPr>
+      <p:grpSpPr/>
+      <p:sp>
+        <p:nvSpPr>
+          <p:cNvPr id="2" name="Title 1"/>
+          <p:cNvSpPr>
+            <a:spLocks noGrp="1"/>
+          </p:cNvSpPr>
+          <p:nvPr>
+            <p:ph type="title"/>
+          </p:nvPr>
+        </p:nvSpPr>
+        <p:spPr/>
+        <p:txBody>
+          <a:bodyPr/>
+          <a:lstStyle/>
+          <a:p>
+            <a:r>
+              <a:t>Dashboard Screenshots</a:t>
+            </a:r>
+          </a:p>
+        </p:txBody>
+      </p:sp>
+      <p:sp>
+        <p:nvSpPr>
+          <p:cNvPr id="3" name="Content Placeholder 2"/>
+          <p:cNvSpPr>
+            <a:spLocks noGrp="1"/>
+          </p:cNvSpPr>
+          <p:nvPr>
+            <p:ph idx="1"/>
+          </p:nvPr>
+        </p:nvSpPr>
+        <p:spPr/>
+        <p:txBody>
+          <a:bodyPr/>
+          <a:lstStyle/>
+          <a:p>
+            <a:pPr>
+              <a:defRPr sz="1800"/>
+            </a:pPr>
+            <a:r>
+              <a:t>Visual dashboards illustrate comparative fund performance, investor analytics, and portfolio risk snapshots.</a:t>
             </a:r>
           </a:p>
         </p:txBody>

</xml_diff>